<commit_message>
Sync pitch deck: new Columbia/Charlotte/Kids pricing matrix
</commit_message>
<xml_diff>
--- a/pitch.pptx
+++ b/pitch.pptx
@@ -2992,7 +2992,7 @@
           </p:nvPr>
         </p:nvGraphicFramePr>
         <p:xfrm>
-          <a:off x="548640" y="1600200"/>
+          <a:off x="548640" y="1554480"/>
           <a:ext cx="8046720" cy="914400"/>
         </p:xfrm>
         <a:graphic>
@@ -3000,11 +3000,12 @@
             <a:tbl>
               <a:tblPr/>
               <a:tblGrid>
-                <a:gridCol w="2103120"/>
-                <a:gridCol w="1371600"/>
-                <a:gridCol w="4572000"/>
+                <a:gridCol w="1828800"/>
+                <a:gridCol w="1463040"/>
+                <a:gridCol w="1463040"/>
+                <a:gridCol w="3291840"/>
               </a:tblGrid>
-              <a:tr h="411480">
+              <a:tr h="347472">
                 <a:tc>
                   <a:txBody>
                     <a:bodyPr/>
@@ -3078,7 +3079,7 @@
                     <a:bodyPr/>
                     <a:lstStyle/>
                     <a:p>
-                      <a:pPr indent="0" marL="0">
+                      <a:pPr algn="ctr" indent="0" marL="0">
                         <a:buNone/>
                       </a:pPr>
                       <a:r>
@@ -3090,7 +3091,7 @@
                           <a:ea typeface="Oswald" pitchFamily="34" charset="-122"/>
                           <a:cs typeface="Oswald" pitchFamily="34" charset="-120"/>
                         </a:rPr>
-                        <a:t>PRICE</a:t>
+                        <a:t>COLUMBIA</a:t>
                       </a:r>
                       <a:endParaRPr lang="en-US" sz="1200" dirty="0">
                         <a:latin typeface="Oswald" charset="0"/>
@@ -3137,7 +3138,7 @@
                       <a:tailEnd type="none" w="med" len="med"/>
                     </a:lnB>
                     <a:solidFill>
-                      <a:srgbClr val="1A1A1A"/>
+                      <a:srgbClr val="CC2529"/>
                     </a:solidFill>
                   </a:tcPr>
                 </a:tc>
@@ -3146,7 +3147,7 @@
                     <a:bodyPr/>
                     <a:lstStyle/>
                     <a:p>
-                      <a:pPr indent="0" marL="0">
+                      <a:pPr algn="ctr" indent="0" marL="0">
                         <a:buNone/>
                       </a:pPr>
                       <a:r>
@@ -3158,7 +3159,75 @@
                           <a:ea typeface="Oswald" pitchFamily="34" charset="-122"/>
                           <a:cs typeface="Oswald" pitchFamily="34" charset="-120"/>
                         </a:rPr>
-                        <a:t>WHAT YOU GET</a:t>
+                        <a:t>CHARLOTTE</a:t>
+                      </a:r>
+                      <a:endParaRPr lang="en-US" sz="1200" dirty="0">
+                        <a:latin typeface="Oswald" charset="0"/>
+                        <a:ea typeface="Oswald" charset="0"/>
+                        <a:cs typeface="Oswald" charset="0"/>
+                      </a:endParaRPr>
+                    </a:p>
+                  </a:txBody>
+                  <a:tcPr marL="91440" marR="91440" marT="45720" marB="45720" anchor="ctr">
+                    <a:lnL w="12700" cap="flat" cmpd="sng" algn="ctr">
+                      <a:solidFill>
+                        <a:srgbClr val="C9BFAE"/>
+                      </a:solidFill>
+                      <a:prstDash val="solid"/>
+                      <a:round/>
+                      <a:headEnd type="none" w="med" len="med"/>
+                      <a:tailEnd type="none" w="med" len="med"/>
+                    </a:lnL>
+                    <a:lnR w="12700" cap="flat" cmpd="sng" algn="ctr">
+                      <a:solidFill>
+                        <a:srgbClr val="C9BFAE"/>
+                      </a:solidFill>
+                      <a:prstDash val="solid"/>
+                      <a:round/>
+                      <a:headEnd type="none" w="med" len="med"/>
+                      <a:tailEnd type="none" w="med" len="med"/>
+                    </a:lnR>
+                    <a:lnT w="12700" cap="flat" cmpd="sng" algn="ctr">
+                      <a:solidFill>
+                        <a:srgbClr val="C9BFAE"/>
+                      </a:solidFill>
+                      <a:prstDash val="solid"/>
+                      <a:round/>
+                      <a:headEnd type="none" w="med" len="med"/>
+                      <a:tailEnd type="none" w="med" len="med"/>
+                    </a:lnT>
+                    <a:lnB w="12700" cap="flat" cmpd="sng" algn="ctr">
+                      <a:solidFill>
+                        <a:srgbClr val="C9BFAE"/>
+                      </a:solidFill>
+                      <a:prstDash val="solid"/>
+                      <a:round/>
+                      <a:headEnd type="none" w="med" len="med"/>
+                      <a:tailEnd type="none" w="med" len="med"/>
+                    </a:lnB>
+                    <a:solidFill>
+                      <a:srgbClr val="C9A84C"/>
+                    </a:solidFill>
+                  </a:tcPr>
+                </a:tc>
+                <a:tc>
+                  <a:txBody>
+                    <a:bodyPr/>
+                    <a:lstStyle/>
+                    <a:p>
+                      <a:pPr algn="ctr" indent="0" marL="0">
+                        <a:buNone/>
+                      </a:pPr>
+                      <a:r>
+                        <a:rPr lang="en-US" sz="1200" b="1" spc="300" kern="0" dirty="0">
+                          <a:solidFill>
+                            <a:srgbClr val="FFFFFF"/>
+                          </a:solidFill>
+                          <a:latin typeface="Oswald" pitchFamily="34" charset="0"/>
+                          <a:ea typeface="Oswald" pitchFamily="34" charset="-122"/>
+                          <a:cs typeface="Oswald" pitchFamily="34" charset="-120"/>
+                        </a:rPr>
+                        <a:t>KIDS</a:t>
                       </a:r>
                       <a:endParaRPr lang="en-US" sz="1200" dirty="0">
                         <a:latin typeface="Oswald" charset="0"/>
@@ -3210,7 +3279,7 @@
                   </a:tcPr>
                 </a:tc>
               </a:tr>
-              <a:tr h="411480">
+              <a:tr h="347472">
                 <a:tc>
                   <a:txBody>
                     <a:bodyPr/>
@@ -3281,7 +3350,7 @@
                     <a:bodyPr/>
                     <a:lstStyle/>
                     <a:p>
-                      <a:pPr indent="0" marL="0">
+                      <a:pPr algn="ctr" indent="0" marL="0">
                         <a:buNone/>
                       </a:pPr>
                       <a:r>
@@ -3346,19 +3415,84 @@
                     <a:bodyPr/>
                     <a:lstStyle/>
                     <a:p>
-                      <a:pPr indent="0" marL="0">
+                      <a:pPr algn="ctr" indent="0" marL="0">
+                        <a:buNone/>
+                      </a:pPr>
+                      <a:r>
+                        <a:rPr lang="en-US" sz="1200" b="1" dirty="0">
+                          <a:solidFill>
+                            <a:srgbClr val="C9A84C"/>
+                          </a:solidFill>
+                          <a:latin typeface="Oswald" pitchFamily="34" charset="0"/>
+                          <a:ea typeface="Oswald" pitchFamily="34" charset="-122"/>
+                          <a:cs typeface="Oswald" pitchFamily="34" charset="-120"/>
+                        </a:rPr>
+                        <a:t>FREE</a:t>
+                      </a:r>
+                      <a:endParaRPr lang="en-US" sz="1200" dirty="0">
+                        <a:latin typeface="Oswald" charset="0"/>
+                        <a:ea typeface="Oswald" charset="0"/>
+                        <a:cs typeface="Oswald" charset="0"/>
+                      </a:endParaRPr>
+                    </a:p>
+                  </a:txBody>
+                  <a:tcPr marL="91440" marR="91440" marT="45720" marB="45720" anchor="ctr">
+                    <a:lnL w="12700" cap="flat" cmpd="sng" algn="ctr">
+                      <a:solidFill>
+                        <a:srgbClr val="C9BFAE"/>
+                      </a:solidFill>
+                      <a:prstDash val="solid"/>
+                      <a:round/>
+                      <a:headEnd type="none" w="med" len="med"/>
+                      <a:tailEnd type="none" w="med" len="med"/>
+                    </a:lnL>
+                    <a:lnR w="12700" cap="flat" cmpd="sng" algn="ctr">
+                      <a:solidFill>
+                        <a:srgbClr val="C9BFAE"/>
+                      </a:solidFill>
+                      <a:prstDash val="solid"/>
+                      <a:round/>
+                      <a:headEnd type="none" w="med" len="med"/>
+                      <a:tailEnd type="none" w="med" len="med"/>
+                    </a:lnR>
+                    <a:lnT w="12700" cap="flat" cmpd="sng" algn="ctr">
+                      <a:solidFill>
+                        <a:srgbClr val="C9BFAE"/>
+                      </a:solidFill>
+                      <a:prstDash val="solid"/>
+                      <a:round/>
+                      <a:headEnd type="none" w="med" len="med"/>
+                      <a:tailEnd type="none" w="med" len="med"/>
+                    </a:lnT>
+                    <a:lnB w="12700" cap="flat" cmpd="sng" algn="ctr">
+                      <a:solidFill>
+                        <a:srgbClr val="C9BFAE"/>
+                      </a:solidFill>
+                      <a:prstDash val="solid"/>
+                      <a:round/>
+                      <a:headEnd type="none" w="med" len="med"/>
+                      <a:tailEnd type="none" w="med" len="med"/>
+                    </a:lnB>
+                  </a:tcPr>
+                </a:tc>
+                <a:tc>
+                  <a:txBody>
+                    <a:bodyPr/>
+                    <a:lstStyle/>
+                    <a:p>
+                      <a:pPr algn="ctr" indent="0" marL="0">
                         <a:buNone/>
                       </a:pPr>
                       <a:r>
                         <a:rPr lang="en-US" sz="1200" dirty="0">
                           <a:solidFill>
-                            <a:srgbClr val="2A2A2A"/>
+                            <a:srgbClr val="6B6358"/>
                           </a:solidFill>
                           <a:latin typeface="Inter" pitchFamily="34" charset="0"/>
                           <a:ea typeface="Inter" pitchFamily="34" charset="-122"/>
                           <a:cs typeface="Inter" pitchFamily="34" charset="-120"/>
                         </a:rPr>
-                        <a:t>Walk in cold. See if Speak Easy is your thing.</a:t>
+                        <a:t>—</a:t>
                       </a:r>
                       <a:endParaRPr lang="en-US" sz="1200" dirty="0">
                         <a:latin typeface="Inter" charset="0"/>
@@ -3407,7 +3541,7 @@
                   </a:tcPr>
                 </a:tc>
               </a:tr>
-              <a:tr h="411480">
+              <a:tr h="347472">
                 <a:tc>
                   <a:txBody>
                     <a:bodyPr/>
@@ -3478,7 +3612,7 @@
                     <a:bodyPr/>
                     <a:lstStyle/>
                     <a:p>
-                      <a:pPr indent="0" marL="0">
+                      <a:pPr algn="ctr" indent="0" marL="0">
                         <a:buNone/>
                       </a:pPr>
                       <a:r>
@@ -3543,19 +3677,84 @@
                     <a:bodyPr/>
                     <a:lstStyle/>
                     <a:p>
-                      <a:pPr indent="0" marL="0">
+                      <a:pPr algn="ctr" indent="0" marL="0">
+                        <a:buNone/>
+                      </a:pPr>
+                      <a:r>
+                        <a:rPr lang="en-US" sz="1200" b="1" dirty="0">
+                          <a:solidFill>
+                            <a:srgbClr val="C9A84C"/>
+                          </a:solidFill>
+                          <a:latin typeface="Oswald" pitchFamily="34" charset="0"/>
+                          <a:ea typeface="Oswald" pitchFamily="34" charset="-122"/>
+                          <a:cs typeface="Oswald" pitchFamily="34" charset="-120"/>
+                        </a:rPr>
+                        <a:t>$10</a:t>
+                      </a:r>
+                      <a:endParaRPr lang="en-US" sz="1200" dirty="0">
+                        <a:latin typeface="Oswald" charset="0"/>
+                        <a:ea typeface="Oswald" charset="0"/>
+                        <a:cs typeface="Oswald" charset="0"/>
+                      </a:endParaRPr>
+                    </a:p>
+                  </a:txBody>
+                  <a:tcPr marL="91440" marR="91440" marT="45720" marB="45720" anchor="ctr">
+                    <a:lnL w="12700" cap="flat" cmpd="sng" algn="ctr">
+                      <a:solidFill>
+                        <a:srgbClr val="C9BFAE"/>
+                      </a:solidFill>
+                      <a:prstDash val="solid"/>
+                      <a:round/>
+                      <a:headEnd type="none" w="med" len="med"/>
+                      <a:tailEnd type="none" w="med" len="med"/>
+                    </a:lnL>
+                    <a:lnR w="12700" cap="flat" cmpd="sng" algn="ctr">
+                      <a:solidFill>
+                        <a:srgbClr val="C9BFAE"/>
+                      </a:solidFill>
+                      <a:prstDash val="solid"/>
+                      <a:round/>
+                      <a:headEnd type="none" w="med" len="med"/>
+                      <a:tailEnd type="none" w="med" len="med"/>
+                    </a:lnR>
+                    <a:lnT w="12700" cap="flat" cmpd="sng" algn="ctr">
+                      <a:solidFill>
+                        <a:srgbClr val="C9BFAE"/>
+                      </a:solidFill>
+                      <a:prstDash val="solid"/>
+                      <a:round/>
+                      <a:headEnd type="none" w="med" len="med"/>
+                      <a:tailEnd type="none" w="med" len="med"/>
+                    </a:lnT>
+                    <a:lnB w="12700" cap="flat" cmpd="sng" algn="ctr">
+                      <a:solidFill>
+                        <a:srgbClr val="C9BFAE"/>
+                      </a:solidFill>
+                      <a:prstDash val="solid"/>
+                      <a:round/>
+                      <a:headEnd type="none" w="med" len="med"/>
+                      <a:tailEnd type="none" w="med" len="med"/>
+                    </a:lnB>
+                  </a:tcPr>
+                </a:tc>
+                <a:tc>
+                  <a:txBody>
+                    <a:bodyPr/>
+                    <a:lstStyle/>
+                    <a:p>
+                      <a:pPr algn="ctr" indent="0" marL="0">
                         <a:buNone/>
                       </a:pPr>
                       <a:r>
                         <a:rPr lang="en-US" sz="1200" dirty="0">
                           <a:solidFill>
-                            <a:srgbClr val="2A2A2A"/>
+                            <a:srgbClr val="6B6358"/>
                           </a:solidFill>
                           <a:latin typeface="Inter" pitchFamily="34" charset="0"/>
                           <a:ea typeface="Inter" pitchFamily="34" charset="-122"/>
                           <a:cs typeface="Inter" pitchFamily="34" charset="-120"/>
                         </a:rPr>
-                        <a:t>Any night, no commitment.</a:t>
+                        <a:t>—</a:t>
                       </a:r>
                       <a:endParaRPr lang="en-US" sz="1200" dirty="0">
                         <a:latin typeface="Inter" charset="0"/>
@@ -3604,7 +3803,7 @@
                   </a:tcPr>
                 </a:tc>
               </a:tr>
-              <a:tr h="411480">
+              <a:tr h="347472">
                 <a:tc>
                   <a:txBody>
                     <a:bodyPr/>
@@ -3675,7 +3874,7 @@
                     <a:bodyPr/>
                     <a:lstStyle/>
                     <a:p>
-                      <a:pPr indent="0" marL="0">
+                      <a:pPr algn="ctr" indent="0" marL="0">
                         <a:buNone/>
                       </a:pPr>
                       <a:r>
@@ -3740,19 +3939,84 @@
                     <a:bodyPr/>
                     <a:lstStyle/>
                     <a:p>
-                      <a:pPr indent="0" marL="0">
+                      <a:pPr algn="ctr" indent="0" marL="0">
                         <a:buNone/>
                       </a:pPr>
                       <a:r>
                         <a:rPr lang="en-US" sz="1200" dirty="0">
                           <a:solidFill>
-                            <a:srgbClr val="2A2A2A"/>
+                            <a:srgbClr val="6B6358"/>
                           </a:solidFill>
                           <a:latin typeface="Inter" pitchFamily="34" charset="0"/>
                           <a:ea typeface="Inter" pitchFamily="34" charset="-122"/>
                           <a:cs typeface="Inter" pitchFamily="34" charset="-120"/>
                         </a:rPr>
-                        <a:t>Columbia only — 3 nights, one price.</a:t>
+                        <a:t>—</a:t>
+                      </a:r>
+                      <a:endParaRPr lang="en-US" sz="1200" dirty="0">
+                        <a:latin typeface="Inter" charset="0"/>
+                        <a:ea typeface="Inter" charset="0"/>
+                        <a:cs typeface="Inter" charset="0"/>
+                      </a:endParaRPr>
+                    </a:p>
+                  </a:txBody>
+                  <a:tcPr marL="91440" marR="91440" marT="45720" marB="45720" anchor="ctr">
+                    <a:lnL w="12700" cap="flat" cmpd="sng" algn="ctr">
+                      <a:solidFill>
+                        <a:srgbClr val="C9BFAE"/>
+                      </a:solidFill>
+                      <a:prstDash val="solid"/>
+                      <a:round/>
+                      <a:headEnd type="none" w="med" len="med"/>
+                      <a:tailEnd type="none" w="med" len="med"/>
+                    </a:lnL>
+                    <a:lnR w="12700" cap="flat" cmpd="sng" algn="ctr">
+                      <a:solidFill>
+                        <a:srgbClr val="C9BFAE"/>
+                      </a:solidFill>
+                      <a:prstDash val="solid"/>
+                      <a:round/>
+                      <a:headEnd type="none" w="med" len="med"/>
+                      <a:tailEnd type="none" w="med" len="med"/>
+                    </a:lnR>
+                    <a:lnT w="12700" cap="flat" cmpd="sng" algn="ctr">
+                      <a:solidFill>
+                        <a:srgbClr val="C9BFAE"/>
+                      </a:solidFill>
+                      <a:prstDash val="solid"/>
+                      <a:round/>
+                      <a:headEnd type="none" w="med" len="med"/>
+                      <a:tailEnd type="none" w="med" len="med"/>
+                    </a:lnT>
+                    <a:lnB w="12700" cap="flat" cmpd="sng" algn="ctr">
+                      <a:solidFill>
+                        <a:srgbClr val="C9BFAE"/>
+                      </a:solidFill>
+                      <a:prstDash val="solid"/>
+                      <a:round/>
+                      <a:headEnd type="none" w="med" len="med"/>
+                      <a:tailEnd type="none" w="med" len="med"/>
+                    </a:lnB>
+                  </a:tcPr>
+                </a:tc>
+                <a:tc>
+                  <a:txBody>
+                    <a:bodyPr/>
+                    <a:lstStyle/>
+                    <a:p>
+                      <a:pPr algn="ctr" indent="0" marL="0">
+                        <a:buNone/>
+                      </a:pPr>
+                      <a:r>
+                        <a:rPr lang="en-US" sz="1200" dirty="0">
+                          <a:solidFill>
+                            <a:srgbClr val="6B6358"/>
+                          </a:solidFill>
+                          <a:latin typeface="Inter" pitchFamily="34" charset="0"/>
+                          <a:ea typeface="Inter" pitchFamily="34" charset="-122"/>
+                          <a:cs typeface="Inter" pitchFamily="34" charset="-120"/>
+                        </a:rPr>
+                        <a:t>—</a:t>
                       </a:r>
                       <a:endParaRPr lang="en-US" sz="1200" dirty="0">
                         <a:latin typeface="Inter" charset="0"/>
@@ -3801,7 +4065,7 @@
                   </a:tcPr>
                 </a:tc>
               </a:tr>
-              <a:tr h="411480">
+              <a:tr h="347472">
                 <a:tc>
                   <a:txBody>
                     <a:bodyPr/>
@@ -3872,7 +4136,7 @@
                     <a:bodyPr/>
                     <a:lstStyle/>
                     <a:p>
-                      <a:pPr indent="0" marL="0">
+                      <a:pPr algn="ctr" indent="0" marL="0">
                         <a:buNone/>
                       </a:pPr>
                       <a:r>
@@ -3937,19 +4201,84 @@
                     <a:bodyPr/>
                     <a:lstStyle/>
                     <a:p>
-                      <a:pPr indent="0" marL="0">
+                      <a:pPr algn="ctr" indent="0" marL="0">
+                        <a:buNone/>
+                      </a:pPr>
+                      <a:r>
+                        <a:rPr lang="en-US" sz="1200" b="1" dirty="0">
+                          <a:solidFill>
+                            <a:srgbClr val="C9A84C"/>
+                          </a:solidFill>
+                          <a:latin typeface="Oswald" pitchFamily="34" charset="0"/>
+                          <a:ea typeface="Oswald" pitchFamily="34" charset="-122"/>
+                          <a:cs typeface="Oswald" pitchFamily="34" charset="-120"/>
+                        </a:rPr>
+                        <a:t>$50</a:t>
+                      </a:r>
+                      <a:endParaRPr lang="en-US" sz="1200" dirty="0">
+                        <a:latin typeface="Oswald" charset="0"/>
+                        <a:ea typeface="Oswald" charset="0"/>
+                        <a:cs typeface="Oswald" charset="0"/>
+                      </a:endParaRPr>
+                    </a:p>
+                  </a:txBody>
+                  <a:tcPr marL="91440" marR="91440" marT="45720" marB="45720" anchor="ctr">
+                    <a:lnL w="12700" cap="flat" cmpd="sng" algn="ctr">
+                      <a:solidFill>
+                        <a:srgbClr val="C9BFAE"/>
+                      </a:solidFill>
+                      <a:prstDash val="solid"/>
+                      <a:round/>
+                      <a:headEnd type="none" w="med" len="med"/>
+                      <a:tailEnd type="none" w="med" len="med"/>
+                    </a:lnL>
+                    <a:lnR w="12700" cap="flat" cmpd="sng" algn="ctr">
+                      <a:solidFill>
+                        <a:srgbClr val="C9BFAE"/>
+                      </a:solidFill>
+                      <a:prstDash val="solid"/>
+                      <a:round/>
+                      <a:headEnd type="none" w="med" len="med"/>
+                      <a:tailEnd type="none" w="med" len="med"/>
+                    </a:lnR>
+                    <a:lnT w="12700" cap="flat" cmpd="sng" algn="ctr">
+                      <a:solidFill>
+                        <a:srgbClr val="C9BFAE"/>
+                      </a:solidFill>
+                      <a:prstDash val="solid"/>
+                      <a:round/>
+                      <a:headEnd type="none" w="med" len="med"/>
+                      <a:tailEnd type="none" w="med" len="med"/>
+                    </a:lnT>
+                    <a:lnB w="12700" cap="flat" cmpd="sng" algn="ctr">
+                      <a:solidFill>
+                        <a:srgbClr val="C9BFAE"/>
+                      </a:solidFill>
+                      <a:prstDash val="solid"/>
+                      <a:round/>
+                      <a:headEnd type="none" w="med" len="med"/>
+                      <a:tailEnd type="none" w="med" len="med"/>
+                    </a:lnB>
+                  </a:tcPr>
+                </a:tc>
+                <a:tc>
+                  <a:txBody>
+                    <a:bodyPr/>
+                    <a:lstStyle/>
+                    <a:p>
+                      <a:pPr algn="ctr" indent="0" marL="0">
                         <a:buNone/>
                       </a:pPr>
                       <a:r>
                         <a:rPr lang="en-US" sz="1200" dirty="0">
                           <a:solidFill>
-                            <a:srgbClr val="2A2A2A"/>
+                            <a:srgbClr val="6B6358"/>
                           </a:solidFill>
                           <a:latin typeface="Inter" pitchFamily="34" charset="0"/>
                           <a:ea typeface="Inter" pitchFamily="34" charset="-122"/>
                           <a:cs typeface="Inter" pitchFamily="34" charset="-120"/>
                         </a:rPr>
-                        <a:t>Every night for 30 days. Best value.</a:t>
+                        <a:t>—</a:t>
                       </a:r>
                       <a:endParaRPr lang="en-US" sz="1200" dirty="0">
                         <a:latin typeface="Inter" charset="0"/>
@@ -3998,7 +4327,7 @@
                   </a:tcPr>
                 </a:tc>
               </a:tr>
-              <a:tr h="411480">
+              <a:tr h="347472">
                 <a:tc>
                   <a:txBody>
                     <a:bodyPr/>
@@ -4069,7 +4398,7 @@
                     <a:bodyPr/>
                     <a:lstStyle/>
                     <a:p>
-                      <a:pPr indent="0" marL="0">
+                      <a:pPr algn="ctr" indent="0" marL="0">
                         <a:buNone/>
                       </a:pPr>
                       <a:r>
@@ -4134,86 +4463,19 @@
                     <a:bodyPr/>
                     <a:lstStyle/>
                     <a:p>
-                      <a:pPr indent="0" marL="0">
+                      <a:pPr algn="ctr" indent="0" marL="0">
                         <a:buNone/>
                       </a:pPr>
                       <a:r>
                         <a:rPr lang="en-US" sz="1200" dirty="0">
                           <a:solidFill>
-                            <a:srgbClr val="2A2A2A"/>
+                            <a:srgbClr val="6B6358"/>
                           </a:solidFill>
                           <a:latin typeface="Inter" pitchFamily="34" charset="0"/>
                           <a:ea typeface="Inter" pitchFamily="34" charset="-122"/>
                           <a:cs typeface="Inter" pitchFamily="34" charset="-120"/>
                         </a:rPr>
-                        <a:t>Curriculum + showcase. Real progress.</a:t>
-                      </a:r>
-                      <a:endParaRPr lang="en-US" sz="1200" dirty="0">
-                        <a:latin typeface="Inter" charset="0"/>
-                        <a:ea typeface="Inter" charset="0"/>
-                        <a:cs typeface="Inter" charset="0"/>
-                      </a:endParaRPr>
-                    </a:p>
-                  </a:txBody>
-                  <a:tcPr marL="91440" marR="91440" marT="45720" marB="45720" anchor="ctr">
-                    <a:lnL w="12700" cap="flat" cmpd="sng" algn="ctr">
-                      <a:solidFill>
-                        <a:srgbClr val="C9BFAE"/>
-                      </a:solidFill>
-                      <a:prstDash val="solid"/>
-                      <a:round/>
-                      <a:headEnd type="none" w="med" len="med"/>
-                      <a:tailEnd type="none" w="med" len="med"/>
-                    </a:lnL>
-                    <a:lnR w="12700" cap="flat" cmpd="sng" algn="ctr">
-                      <a:solidFill>
-                        <a:srgbClr val="C9BFAE"/>
-                      </a:solidFill>
-                      <a:prstDash val="solid"/>
-                      <a:round/>
-                      <a:headEnd type="none" w="med" len="med"/>
-                      <a:tailEnd type="none" w="med" len="med"/>
-                    </a:lnR>
-                    <a:lnT w="12700" cap="flat" cmpd="sng" algn="ctr">
-                      <a:solidFill>
-                        <a:srgbClr val="C9BFAE"/>
-                      </a:solidFill>
-                      <a:prstDash val="solid"/>
-                      <a:round/>
-                      <a:headEnd type="none" w="med" len="med"/>
-                      <a:tailEnd type="none" w="med" len="med"/>
-                    </a:lnT>
-                    <a:lnB w="12700" cap="flat" cmpd="sng" algn="ctr">
-                      <a:solidFill>
-                        <a:srgbClr val="C9BFAE"/>
-                      </a:solidFill>
-                      <a:prstDash val="solid"/>
-                      <a:round/>
-                      <a:headEnd type="none" w="med" len="med"/>
-                      <a:tailEnd type="none" w="med" len="med"/>
-                    </a:lnB>
-                  </a:tcPr>
-                </a:tc>
-              </a:tr>
-              <a:tr h="411480">
-                <a:tc>
-                  <a:txBody>
-                    <a:bodyPr/>
-                    <a:lstStyle/>
-                    <a:p>
-                      <a:pPr indent="0" marL="0">
-                        <a:buNone/>
-                      </a:pPr>
-                      <a:r>
-                        <a:rPr lang="en-US" sz="1200" b="1" dirty="0">
-                          <a:solidFill>
-                            <a:srgbClr val="2A2A2A"/>
-                          </a:solidFill>
-                          <a:latin typeface="Inter" pitchFamily="34" charset="0"/>
-                          <a:ea typeface="Inter" pitchFamily="34" charset="-122"/>
-                          <a:cs typeface="Inter" pitchFamily="34" charset="-120"/>
-                        </a:rPr>
-                        <a:t>Kids 8-wk</a:t>
+                        <a:t>—</a:t>
                       </a:r>
                       <a:endParaRPr lang="en-US" sz="1200" dirty="0">
                         <a:latin typeface="Inter" charset="0"/>
@@ -4266,84 +4528,19 @@
                     <a:bodyPr/>
                     <a:lstStyle/>
                     <a:p>
-                      <a:pPr indent="0" marL="0">
-                        <a:buNone/>
-                      </a:pPr>
-                      <a:r>
-                        <a:rPr lang="en-US" sz="1200" b="1" dirty="0">
-                          <a:solidFill>
-                            <a:srgbClr val="6B6358"/>
-                          </a:solidFill>
-                          <a:latin typeface="Oswald" pitchFamily="34" charset="0"/>
-                          <a:ea typeface="Oswald" pitchFamily="34" charset="-122"/>
-                          <a:cs typeface="Oswald" pitchFamily="34" charset="-120"/>
-                        </a:rPr>
-                        <a:t>TBD</a:t>
-                      </a:r>
-                      <a:endParaRPr lang="en-US" sz="1200" dirty="0">
-                        <a:latin typeface="Oswald" charset="0"/>
-                        <a:ea typeface="Oswald" charset="0"/>
-                        <a:cs typeface="Oswald" charset="0"/>
-                      </a:endParaRPr>
-                    </a:p>
-                  </a:txBody>
-                  <a:tcPr marL="91440" marR="91440" marT="45720" marB="45720" anchor="ctr">
-                    <a:lnL w="12700" cap="flat" cmpd="sng" algn="ctr">
-                      <a:solidFill>
-                        <a:srgbClr val="C9BFAE"/>
-                      </a:solidFill>
-                      <a:prstDash val="solid"/>
-                      <a:round/>
-                      <a:headEnd type="none" w="med" len="med"/>
-                      <a:tailEnd type="none" w="med" len="med"/>
-                    </a:lnL>
-                    <a:lnR w="12700" cap="flat" cmpd="sng" algn="ctr">
-                      <a:solidFill>
-                        <a:srgbClr val="C9BFAE"/>
-                      </a:solidFill>
-                      <a:prstDash val="solid"/>
-                      <a:round/>
-                      <a:headEnd type="none" w="med" len="med"/>
-                      <a:tailEnd type="none" w="med" len="med"/>
-                    </a:lnR>
-                    <a:lnT w="12700" cap="flat" cmpd="sng" algn="ctr">
-                      <a:solidFill>
-                        <a:srgbClr val="C9BFAE"/>
-                      </a:solidFill>
-                      <a:prstDash val="solid"/>
-                      <a:round/>
-                      <a:headEnd type="none" w="med" len="med"/>
-                      <a:tailEnd type="none" w="med" len="med"/>
-                    </a:lnT>
-                    <a:lnB w="12700" cap="flat" cmpd="sng" algn="ctr">
-                      <a:solidFill>
-                        <a:srgbClr val="C9BFAE"/>
-                      </a:solidFill>
-                      <a:prstDash val="solid"/>
-                      <a:round/>
-                      <a:headEnd type="none" w="med" len="med"/>
-                      <a:tailEnd type="none" w="med" len="med"/>
-                    </a:lnB>
-                  </a:tcPr>
-                </a:tc>
-                <a:tc>
-                  <a:txBody>
-                    <a:bodyPr/>
-                    <a:lstStyle/>
-                    <a:p>
-                      <a:pPr indent="0" marL="0">
+                      <a:pPr algn="ctr" indent="0" marL="0">
                         <a:buNone/>
                       </a:pPr>
                       <a:r>
                         <a:rPr lang="en-US" sz="1200" dirty="0">
                           <a:solidFill>
-                            <a:srgbClr val="2A2A2A"/>
+                            <a:srgbClr val="6B6358"/>
                           </a:solidFill>
                           <a:latin typeface="Inter" pitchFamily="34" charset="0"/>
                           <a:ea typeface="Inter" pitchFamily="34" charset="-122"/>
                           <a:cs typeface="Inter" pitchFamily="34" charset="-120"/>
                         </a:rPr>
-                        <a:t>Afterschool Spanish, K–5. Pilot pricing.</a:t>
+                        <a:t>—</a:t>
                       </a:r>
                       <a:endParaRPr lang="en-US" sz="1200" dirty="0">
                         <a:latin typeface="Inter" charset="0"/>
@@ -4392,13 +4589,314 @@
                   </a:tcPr>
                 </a:tc>
               </a:tr>
+              <a:tr h="347472">
+                <a:tc>
+                  <a:txBody>
+                    <a:bodyPr/>
+                    <a:lstStyle/>
+                    <a:p>
+                      <a:pPr indent="0" marL="0">
+                        <a:buNone/>
+                      </a:pPr>
+                      <a:r>
+                        <a:rPr lang="en-US" sz="1200" b="1" dirty="0">
+                          <a:solidFill>
+                            <a:srgbClr val="2A2A2A"/>
+                          </a:solidFill>
+                          <a:latin typeface="Inter" pitchFamily="34" charset="0"/>
+                          <a:ea typeface="Inter" pitchFamily="34" charset="-122"/>
+                          <a:cs typeface="Inter" pitchFamily="34" charset="-120"/>
+                        </a:rPr>
+                        <a:t>8-week session</a:t>
+                      </a:r>
+                      <a:endParaRPr lang="en-US" sz="1200" dirty="0">
+                        <a:latin typeface="Inter" charset="0"/>
+                        <a:ea typeface="Inter" charset="0"/>
+                        <a:cs typeface="Inter" charset="0"/>
+                      </a:endParaRPr>
+                    </a:p>
+                  </a:txBody>
+                  <a:tcPr marL="91440" marR="91440" marT="45720" marB="45720" anchor="ctr">
+                    <a:lnL w="12700" cap="flat" cmpd="sng" algn="ctr">
+                      <a:solidFill>
+                        <a:srgbClr val="C9BFAE"/>
+                      </a:solidFill>
+                      <a:prstDash val="solid"/>
+                      <a:round/>
+                      <a:headEnd type="none" w="med" len="med"/>
+                      <a:tailEnd type="none" w="med" len="med"/>
+                    </a:lnL>
+                    <a:lnR w="12700" cap="flat" cmpd="sng" algn="ctr">
+                      <a:solidFill>
+                        <a:srgbClr val="C9BFAE"/>
+                      </a:solidFill>
+                      <a:prstDash val="solid"/>
+                      <a:round/>
+                      <a:headEnd type="none" w="med" len="med"/>
+                      <a:tailEnd type="none" w="med" len="med"/>
+                    </a:lnR>
+                    <a:lnT w="12700" cap="flat" cmpd="sng" algn="ctr">
+                      <a:solidFill>
+                        <a:srgbClr val="C9BFAE"/>
+                      </a:solidFill>
+                      <a:prstDash val="solid"/>
+                      <a:round/>
+                      <a:headEnd type="none" w="med" len="med"/>
+                      <a:tailEnd type="none" w="med" len="med"/>
+                    </a:lnT>
+                    <a:lnB w="12700" cap="flat" cmpd="sng" algn="ctr">
+                      <a:solidFill>
+                        <a:srgbClr val="C9BFAE"/>
+                      </a:solidFill>
+                      <a:prstDash val="solid"/>
+                      <a:round/>
+                      <a:headEnd type="none" w="med" len="med"/>
+                      <a:tailEnd type="none" w="med" len="med"/>
+                    </a:lnB>
+                  </a:tcPr>
+                </a:tc>
+                <a:tc>
+                  <a:txBody>
+                    <a:bodyPr/>
+                    <a:lstStyle/>
+                    <a:p>
+                      <a:pPr algn="ctr" indent="0" marL="0">
+                        <a:buNone/>
+                      </a:pPr>
+                      <a:r>
+                        <a:rPr lang="en-US" sz="1200" dirty="0">
+                          <a:solidFill>
+                            <a:srgbClr val="6B6358"/>
+                          </a:solidFill>
+                          <a:latin typeface="Inter" pitchFamily="34" charset="0"/>
+                          <a:ea typeface="Inter" pitchFamily="34" charset="-122"/>
+                          <a:cs typeface="Inter" pitchFamily="34" charset="-120"/>
+                        </a:rPr>
+                        <a:t>—</a:t>
+                      </a:r>
+                      <a:endParaRPr lang="en-US" sz="1200" dirty="0">
+                        <a:latin typeface="Inter" charset="0"/>
+                        <a:ea typeface="Inter" charset="0"/>
+                        <a:cs typeface="Inter" charset="0"/>
+                      </a:endParaRPr>
+                    </a:p>
+                  </a:txBody>
+                  <a:tcPr marL="91440" marR="91440" marT="45720" marB="45720" anchor="ctr">
+                    <a:lnL w="12700" cap="flat" cmpd="sng" algn="ctr">
+                      <a:solidFill>
+                        <a:srgbClr val="C9BFAE"/>
+                      </a:solidFill>
+                      <a:prstDash val="solid"/>
+                      <a:round/>
+                      <a:headEnd type="none" w="med" len="med"/>
+                      <a:tailEnd type="none" w="med" len="med"/>
+                    </a:lnL>
+                    <a:lnR w="12700" cap="flat" cmpd="sng" algn="ctr">
+                      <a:solidFill>
+                        <a:srgbClr val="C9BFAE"/>
+                      </a:solidFill>
+                      <a:prstDash val="solid"/>
+                      <a:round/>
+                      <a:headEnd type="none" w="med" len="med"/>
+                      <a:tailEnd type="none" w="med" len="med"/>
+                    </a:lnR>
+                    <a:lnT w="12700" cap="flat" cmpd="sng" algn="ctr">
+                      <a:solidFill>
+                        <a:srgbClr val="C9BFAE"/>
+                      </a:solidFill>
+                      <a:prstDash val="solid"/>
+                      <a:round/>
+                      <a:headEnd type="none" w="med" len="med"/>
+                      <a:tailEnd type="none" w="med" len="med"/>
+                    </a:lnT>
+                    <a:lnB w="12700" cap="flat" cmpd="sng" algn="ctr">
+                      <a:solidFill>
+                        <a:srgbClr val="C9BFAE"/>
+                      </a:solidFill>
+                      <a:prstDash val="solid"/>
+                      <a:round/>
+                      <a:headEnd type="none" w="med" len="med"/>
+                      <a:tailEnd type="none" w="med" len="med"/>
+                    </a:lnB>
+                  </a:tcPr>
+                </a:tc>
+                <a:tc>
+                  <a:txBody>
+                    <a:bodyPr/>
+                    <a:lstStyle/>
+                    <a:p>
+                      <a:pPr algn="ctr" indent="0" marL="0">
+                        <a:buNone/>
+                      </a:pPr>
+                      <a:r>
+                        <a:rPr lang="en-US" sz="1200" dirty="0">
+                          <a:solidFill>
+                            <a:srgbClr val="6B6358"/>
+                          </a:solidFill>
+                          <a:latin typeface="Inter" pitchFamily="34" charset="0"/>
+                          <a:ea typeface="Inter" pitchFamily="34" charset="-122"/>
+                          <a:cs typeface="Inter" pitchFamily="34" charset="-120"/>
+                        </a:rPr>
+                        <a:t>—</a:t>
+                      </a:r>
+                      <a:endParaRPr lang="en-US" sz="1200" dirty="0">
+                        <a:latin typeface="Inter" charset="0"/>
+                        <a:ea typeface="Inter" charset="0"/>
+                        <a:cs typeface="Inter" charset="0"/>
+                      </a:endParaRPr>
+                    </a:p>
+                  </a:txBody>
+                  <a:tcPr marL="91440" marR="91440" marT="45720" marB="45720" anchor="ctr">
+                    <a:lnL w="12700" cap="flat" cmpd="sng" algn="ctr">
+                      <a:solidFill>
+                        <a:srgbClr val="C9BFAE"/>
+                      </a:solidFill>
+                      <a:prstDash val="solid"/>
+                      <a:round/>
+                      <a:headEnd type="none" w="med" len="med"/>
+                      <a:tailEnd type="none" w="med" len="med"/>
+                    </a:lnL>
+                    <a:lnR w="12700" cap="flat" cmpd="sng" algn="ctr">
+                      <a:solidFill>
+                        <a:srgbClr val="C9BFAE"/>
+                      </a:solidFill>
+                      <a:prstDash val="solid"/>
+                      <a:round/>
+                      <a:headEnd type="none" w="med" len="med"/>
+                      <a:tailEnd type="none" w="med" len="med"/>
+                    </a:lnR>
+                    <a:lnT w="12700" cap="flat" cmpd="sng" algn="ctr">
+                      <a:solidFill>
+                        <a:srgbClr val="C9BFAE"/>
+                      </a:solidFill>
+                      <a:prstDash val="solid"/>
+                      <a:round/>
+                      <a:headEnd type="none" w="med" len="med"/>
+                      <a:tailEnd type="none" w="med" len="med"/>
+                    </a:lnT>
+                    <a:lnB w="12700" cap="flat" cmpd="sng" algn="ctr">
+                      <a:solidFill>
+                        <a:srgbClr val="C9BFAE"/>
+                      </a:solidFill>
+                      <a:prstDash val="solid"/>
+                      <a:round/>
+                      <a:headEnd type="none" w="med" len="med"/>
+                      <a:tailEnd type="none" w="med" len="med"/>
+                    </a:lnB>
+                  </a:tcPr>
+                </a:tc>
+                <a:tc>
+                  <a:txBody>
+                    <a:bodyPr/>
+                    <a:lstStyle/>
+                    <a:p>
+                      <a:pPr algn="ctr" indent="0" marL="0">
+                        <a:buNone/>
+                      </a:pPr>
+                      <a:r>
+                        <a:rPr lang="en-US" sz="1000" b="1" dirty="0">
+                          <a:solidFill>
+                            <a:srgbClr val="1A1A1A"/>
+                          </a:solidFill>
+                          <a:latin typeface="Oswald" pitchFamily="34" charset="0"/>
+                          <a:ea typeface="Oswald" pitchFamily="34" charset="-122"/>
+                          <a:cs typeface="Oswald" pitchFamily="34" charset="-120"/>
+                        </a:rPr>
+                        <a:t>$129 school · $300 in-home</a:t>
+                      </a:r>
+                      <a:endParaRPr lang="en-US" sz="1000" dirty="0">
+                        <a:latin typeface="Oswald" charset="0"/>
+                        <a:ea typeface="Oswald" charset="0"/>
+                        <a:cs typeface="Oswald" charset="0"/>
+                      </a:endParaRPr>
+                    </a:p>
+                  </a:txBody>
+                  <a:tcPr marL="91440" marR="91440" marT="45720" marB="45720" anchor="ctr">
+                    <a:lnL w="12700" cap="flat" cmpd="sng" algn="ctr">
+                      <a:solidFill>
+                        <a:srgbClr val="C9BFAE"/>
+                      </a:solidFill>
+                      <a:prstDash val="solid"/>
+                      <a:round/>
+                      <a:headEnd type="none" w="med" len="med"/>
+                      <a:tailEnd type="none" w="med" len="med"/>
+                    </a:lnL>
+                    <a:lnR w="12700" cap="flat" cmpd="sng" algn="ctr">
+                      <a:solidFill>
+                        <a:srgbClr val="C9BFAE"/>
+                      </a:solidFill>
+                      <a:prstDash val="solid"/>
+                      <a:round/>
+                      <a:headEnd type="none" w="med" len="med"/>
+                      <a:tailEnd type="none" w="med" len="med"/>
+                    </a:lnR>
+                    <a:lnT w="12700" cap="flat" cmpd="sng" algn="ctr">
+                      <a:solidFill>
+                        <a:srgbClr val="C9BFAE"/>
+                      </a:solidFill>
+                      <a:prstDash val="solid"/>
+                      <a:round/>
+                      <a:headEnd type="none" w="med" len="med"/>
+                      <a:tailEnd type="none" w="med" len="med"/>
+                    </a:lnT>
+                    <a:lnB w="12700" cap="flat" cmpd="sng" algn="ctr">
+                      <a:solidFill>
+                        <a:srgbClr val="C9BFAE"/>
+                      </a:solidFill>
+                      <a:prstDash val="solid"/>
+                      <a:round/>
+                      <a:headEnd type="none" w="med" len="med"/>
+                      <a:tailEnd type="none" w="med" len="med"/>
+                    </a:lnB>
+                  </a:tcPr>
+                </a:tc>
+              </a:tr>
             </a:tbl>
           </a:graphicData>
         </a:graphic>
       </p:graphicFrame>
       <p:sp>
         <p:nvSpPr>
-          <p:cNvPr id="6" name="Shape 3"/>
+          <p:cNvPr id="6" name="Text 3"/>
+          <p:cNvSpPr/>
+          <p:nvPr/>
+        </p:nvSpPr>
+        <p:spPr>
+          <a:xfrm>
+            <a:off x="548640" y="4114800"/>
+            <a:ext cx="8046720" cy="320040"/>
+          </a:xfrm>
+          <a:prstGeom prst="rect">
+            <a:avLst/>
+          </a:prstGeom>
+          <a:noFill/>
+          <a:ln/>
+        </p:spPr>
+        <p:txBody>
+          <a:bodyPr wrap="square" rtlCol="0" anchor="ctr"/>
+          <a:lstStyle/>
+          <a:p>
+            <a:pPr algn="ctr" indent="0" marL="0">
+              <a:buNone/>
+            </a:pPr>
+            <a:r>
+              <a:rPr lang="en-US" sz="1050" i="1" dirty="0">
+                <a:solidFill>
+                  <a:srgbClr val="6B6358"/>
+                </a:solidFill>
+                <a:latin typeface="Inter" pitchFamily="34" charset="0"/>
+                <a:ea typeface="Inter" pitchFamily="34" charset="-122"/>
+                <a:cs typeface="Inter" pitchFamily="34" charset="-120"/>
+              </a:rPr>
+              <a:t>Charlotte includes drink specials at every venue · Columbia and Kids include all materials · No hidden fees anywhere.</a:t>
+            </a:r>
+            <a:endParaRPr lang="en-US" sz="1050" dirty="0"/>
+          </a:p>
+        </p:txBody>
+      </p:sp>
+      <p:sp>
+        <p:nvSpPr>
+          <p:cNvPr id="7" name="Shape 4"/>
           <p:cNvSpPr/>
           <p:nvPr/>
         </p:nvSpPr>
@@ -4418,7 +4916,7 @@
       </p:sp>
       <p:sp>
         <p:nvSpPr>
-          <p:cNvPr id="7" name="Text 4"/>
+          <p:cNvPr id="8" name="Text 5"/>
           <p:cNvSpPr/>
           <p:nvPr/>
         </p:nvSpPr>
@@ -8612,7 +9110,7 @@
                 <a:ea typeface="Inter" pitchFamily="34" charset="-122"/>
                 <a:cs typeface="Inter" pitchFamily="34" charset="-120"/>
               </a:rPr>
-              <a:t>$10 first night · drink discount</a:t>
+              <a:t>Free first night · $50/mo · drink specials</a:t>
             </a:r>
             <a:endParaRPr lang="en-US" sz="1050" dirty="0"/>
           </a:p>
@@ -10750,7 +11248,7 @@
                 <a:ea typeface="Oswald" pitchFamily="34" charset="-122"/>
                 <a:cs typeface="Oswald" pitchFamily="34" charset="-120"/>
               </a:rPr>
-              <a:t>$10 FIRST · $20 DROP-IN · $99 MONTH · $199 THREE-MONTH · DRINK DISCOUNT</a:t>
+              <a:t>FREE FIRST NIGHT · $10 DROP-IN · $50 MONTH · DRINK SPECIALS AT EVERY VENUE</a:t>
             </a:r>
             <a:endParaRPr lang="en-US" sz="1200" dirty="0"/>
           </a:p>

</xml_diff>